<commit_message>
Update PPTX: remove slide 12 and add live Vercel deployment link on last slide
</commit_message>
<xml_diff>
--- a/RIMS_System_Specification.pptx
+++ b/RIMS_System_Specification.pptx
@@ -5949,7 +5949,7 @@
               </a:defRPr>
             </a:pPr>
             <a:r>
-              <a:t>12. Summary &amp; Key Prototype Benefits</a:t>
+              <a:t>12. Summary &amp; Live Prototype Deployment</a:t>
             </a:r>
           </a:p>
         </p:txBody>
@@ -5962,8 +5962,8 @@
         </p:nvSpPr>
         <p:spPr>
           <a:xfrm>
-            <a:off x="914400" y="1371600"/>
-            <a:ext cx="5029200" cy="2103120"/>
+            <a:off x="914400" y="1261872"/>
+            <a:ext cx="5029200" cy="1874519"/>
           </a:xfrm>
           <a:prstGeom prst="roundRect">
             <a:avLst/>
@@ -6007,7 +6007,7 @@
         </p:nvSpPr>
         <p:spPr>
           <a:xfrm>
-            <a:off x="914400" y="1371600"/>
+            <a:off x="914400" y="1261872"/>
             <a:ext cx="5029200" cy="384048"/>
           </a:xfrm>
           <a:prstGeom prst="rect">
@@ -6059,8 +6059,8 @@
         </p:nvSpPr>
         <p:spPr>
           <a:xfrm>
-            <a:off x="1097280" y="1920240"/>
-            <a:ext cx="4663440" cy="1371600"/>
+            <a:off x="1097280" y="1755648"/>
+            <a:ext cx="4663440" cy="1234440"/>
           </a:xfrm>
           <a:prstGeom prst="rect">
             <a:avLst/>
@@ -6075,9 +6075,9 @@
           <a:p>
             <a:pPr>
               <a:lnSpc>
-                <a:spcPct val="130000"/>
+                <a:spcPct val="125000"/>
               </a:lnSpc>
-              <a:defRPr sz="1200">
+              <a:defRPr sz="1100">
                 <a:solidFill>
                   <a:srgbClr val="0F172A"/>
                 </a:solidFill>
@@ -6097,8 +6097,8 @@
         </p:nvSpPr>
         <p:spPr>
           <a:xfrm>
-            <a:off x="6217920" y="1371600"/>
-            <a:ext cx="5029200" cy="2103120"/>
+            <a:off x="6217920" y="1261872"/>
+            <a:ext cx="5029200" cy="1874519"/>
           </a:xfrm>
           <a:prstGeom prst="roundRect">
             <a:avLst/>
@@ -6142,7 +6142,7 @@
         </p:nvSpPr>
         <p:spPr>
           <a:xfrm>
-            <a:off x="6217920" y="1371600"/>
+            <a:off x="6217920" y="1261872"/>
             <a:ext cx="5029200" cy="384048"/>
           </a:xfrm>
           <a:prstGeom prst="rect">
@@ -6194,8 +6194,8 @@
         </p:nvSpPr>
         <p:spPr>
           <a:xfrm>
-            <a:off x="6400800" y="1920240"/>
-            <a:ext cx="4663440" cy="1371600"/>
+            <a:off x="6400800" y="1755648"/>
+            <a:ext cx="4663440" cy="1234440"/>
           </a:xfrm>
           <a:prstGeom prst="rect">
             <a:avLst/>
@@ -6210,9 +6210,9 @@
           <a:p>
             <a:pPr>
               <a:lnSpc>
-                <a:spcPct val="130000"/>
+                <a:spcPct val="125000"/>
               </a:lnSpc>
-              <a:defRPr sz="1200">
+              <a:defRPr sz="1100">
                 <a:solidFill>
                   <a:srgbClr val="0F172A"/>
                 </a:solidFill>
@@ -6232,8 +6232,8 @@
         </p:nvSpPr>
         <p:spPr>
           <a:xfrm>
-            <a:off x="914400" y="3749039"/>
-            <a:ext cx="5029200" cy="2103120"/>
+            <a:off x="914400" y="3273552"/>
+            <a:ext cx="5029200" cy="1874519"/>
           </a:xfrm>
           <a:prstGeom prst="roundRect">
             <a:avLst/>
@@ -6277,7 +6277,7 @@
         </p:nvSpPr>
         <p:spPr>
           <a:xfrm>
-            <a:off x="914400" y="3749039"/>
+            <a:off x="914400" y="3273552"/>
             <a:ext cx="5029200" cy="384048"/>
           </a:xfrm>
           <a:prstGeom prst="rect">
@@ -6329,8 +6329,8 @@
         </p:nvSpPr>
         <p:spPr>
           <a:xfrm>
-            <a:off x="1097280" y="4297680"/>
-            <a:ext cx="4663440" cy="1371600"/>
+            <a:off x="1097280" y="3767328"/>
+            <a:ext cx="4663440" cy="1234440"/>
           </a:xfrm>
           <a:prstGeom prst="rect">
             <a:avLst/>
@@ -6345,9 +6345,9 @@
           <a:p>
             <a:pPr>
               <a:lnSpc>
-                <a:spcPct val="130000"/>
+                <a:spcPct val="125000"/>
               </a:lnSpc>
-              <a:defRPr sz="1200">
+              <a:defRPr sz="1100">
                 <a:solidFill>
                   <a:srgbClr val="0F172A"/>
                 </a:solidFill>
@@ -6367,8 +6367,8 @@
         </p:nvSpPr>
         <p:spPr>
           <a:xfrm>
-            <a:off x="6217920" y="3749039"/>
-            <a:ext cx="5029200" cy="2103120"/>
+            <a:off x="6217920" y="3273552"/>
+            <a:ext cx="5029200" cy="1874519"/>
           </a:xfrm>
           <a:prstGeom prst="roundRect">
             <a:avLst/>
@@ -6412,7 +6412,7 @@
         </p:nvSpPr>
         <p:spPr>
           <a:xfrm>
-            <a:off x="6217920" y="3749039"/>
+            <a:off x="6217920" y="3273552"/>
             <a:ext cx="5029200" cy="384048"/>
           </a:xfrm>
           <a:prstGeom prst="rect">
@@ -6464,8 +6464,8 @@
         </p:nvSpPr>
         <p:spPr>
           <a:xfrm>
-            <a:off x="6400800" y="4297680"/>
-            <a:ext cx="4663440" cy="1371600"/>
+            <a:off x="6400800" y="3767328"/>
+            <a:ext cx="4663440" cy="1234440"/>
           </a:xfrm>
           <a:prstGeom prst="rect">
             <a:avLst/>
@@ -6480,9 +6480,9 @@
           <a:p>
             <a:pPr>
               <a:lnSpc>
-                <a:spcPct val="130000"/>
+                <a:spcPct val="125000"/>
               </a:lnSpc>
-              <a:defRPr sz="1200">
+              <a:defRPr sz="1100">
                 <a:solidFill>
                   <a:srgbClr val="0F172A"/>
                 </a:solidFill>
@@ -6496,7 +6496,102 @@
       </p:sp>
       <p:sp>
         <p:nvSpPr>
-          <p:cNvPr id="18" name="TextBox 17"/>
+          <p:cNvPr id="18" name="Rounded Rectangle 17"/>
+          <p:cNvSpPr/>
+          <p:nvPr/>
+        </p:nvSpPr>
+        <p:spPr>
+          <a:xfrm>
+            <a:off x="914400" y="5440680"/>
+            <a:ext cx="10332720" cy="868680"/>
+          </a:xfrm>
+          <a:prstGeom prst="roundRect">
+            <a:avLst/>
+          </a:prstGeom>
+          <a:solidFill>
+            <a:srgbClr val="0F172A"/>
+          </a:solidFill>
+          <a:ln w="25400">
+            <a:solidFill>
+              <a:srgbClr val="10B981"/>
+            </a:solidFill>
+          </a:ln>
+        </p:spPr>
+        <p:style>
+          <a:lnRef idx="1">
+            <a:schemeClr val="accent1"/>
+          </a:lnRef>
+          <a:fillRef idx="3">
+            <a:schemeClr val="accent1"/>
+          </a:fillRef>
+          <a:effectRef idx="2">
+            <a:schemeClr val="accent1"/>
+          </a:effectRef>
+          <a:fontRef idx="minor">
+            <a:schemeClr val="lt1"/>
+          </a:fontRef>
+        </p:style>
+        <p:txBody>
+          <a:bodyPr rtlCol="0" anchor="ctr"/>
+          <a:lstStyle/>
+          <a:p>
+            <a:pPr algn="ctr"/>
+          </a:p>
+        </p:txBody>
+      </p:sp>
+      <p:sp>
+        <p:nvSpPr>
+          <p:cNvPr id="19" name="TextBox 18"/>
+          <p:cNvSpPr txBox="1"/>
+          <p:nvPr/>
+        </p:nvSpPr>
+        <p:spPr>
+          <a:xfrm>
+            <a:off x="1097280" y="5486400"/>
+            <a:ext cx="9966960" cy="777240"/>
+          </a:xfrm>
+          <a:prstGeom prst="rect">
+            <a:avLst/>
+          </a:prstGeom>
+          <a:noFill/>
+        </p:spPr>
+        <p:txBody>
+          <a:bodyPr wrap="square">
+            <a:spAutoFit/>
+          </a:bodyPr>
+          <a:lstStyle/>
+          <a:p>
+            <a:pPr>
+              <a:defRPr sz="1000" b="1">
+                <a:solidFill>
+                  <a:srgbClr val="0EA5E9"/>
+                </a:solidFill>
+              </a:defRPr>
+            </a:pPr>
+            <a:r>
+              <a:t>🌐 LIVE PRODUCTION DEPLOYMENT (VERCEL)</a:t>
+            </a:r>
+          </a:p>
+          <a:p>
+            <a:pPr>
+              <a:spcBef>
+                <a:spcPts val="200"/>
+              </a:spcBef>
+              <a:defRPr sz="1500" b="1">
+                <a:solidFill>
+                  <a:srgbClr val="10B981"/>
+                </a:solidFill>
+              </a:defRPr>
+            </a:pPr>
+            <a:r>
+              <a:t>https://refrigerator-inventory-system.vercel.app/</a:t>
+            </a:r>
+          </a:p>
+        </p:txBody>
+      </p:sp>
+      <p:sp>
+        <p:nvSpPr>
+          <p:cNvPr id="20" name="TextBox 19"/>
           <p:cNvSpPr txBox="1"/>
           <p:nvPr/>
         </p:nvSpPr>

</xml_diff>

<commit_message>
Update PPTX with high-res UML Class Diagram and CRC Cards diagrams
</commit_message>
<xml_diff>
--- a/RIMS_System_Specification.pptx
+++ b/RIMS_System_Specification.pptx
@@ -3456,42 +3456,6 @@
           </a:p>
         </p:txBody>
       </p:sp>
-      <p:sp>
-        <p:nvSpPr>
-          <p:cNvPr id="9" name="TextBox 8"/>
-          <p:cNvSpPr txBox="1"/>
-          <p:nvPr/>
-        </p:nvSpPr>
-        <p:spPr>
-          <a:xfrm>
-            <a:off x="731520" y="6473952"/>
-            <a:ext cx="10728655" cy="274320"/>
-          </a:xfrm>
-          <a:prstGeom prst="rect">
-            <a:avLst/>
-          </a:prstGeom>
-          <a:noFill/>
-        </p:spPr>
-        <p:txBody>
-          <a:bodyPr wrap="none">
-            <a:spAutoFit/>
-          </a:bodyPr>
-          <a:lstStyle/>
-          <a:p>
-            <a:pPr>
-              <a:defRPr sz="900">
-                <a:solidFill>
-                  <a:srgbClr val="475569"/>
-                </a:solidFill>
-                <a:latin typeface="Arial"/>
-              </a:defRPr>
-            </a:pPr>
-            <a:r>
-              <a:t>Refrigerator &amp; Pantry Inventory System Prototype   •   Slide 1 of 13</a:t>
-            </a:r>
-          </a:p>
-        </p:txBody>
-      </p:sp>
     </p:spTree>
   </p:cSld>
   <p:clrMapOvr>
@@ -7159,9 +7123,7 @@
             <a:srgbClr val="0F172A"/>
           </a:solidFill>
           <a:ln>
-            <a:solidFill>
-              <a:srgbClr val="2563EB"/>
-            </a:solidFill>
+            <a:noFill/>
           </a:ln>
         </p:spPr>
         <p:style>
@@ -7183,57 +7145,12 @@
           <a:lstStyle/>
           <a:p>
             <a:pPr algn="ctr"/>
-            <a:endParaRPr/>
-          </a:p>
-        </p:txBody>
-      </p:sp>
-      <p:sp>
-        <p:nvSpPr>
-          <p:cNvPr id="3" name="Rectangle 2"/>
-          <p:cNvSpPr/>
-          <p:nvPr/>
-        </p:nvSpPr>
-        <p:spPr>
-          <a:xfrm>
-            <a:off x="0" y="1033271"/>
-            <a:ext cx="12191695" cy="36576"/>
-          </a:xfrm>
-          <a:prstGeom prst="rect">
-            <a:avLst/>
-          </a:prstGeom>
-          <a:solidFill>
-            <a:srgbClr val="2563EB"/>
-          </a:solidFill>
-          <a:ln>
-            <a:noFill/>
-          </a:ln>
-        </p:spPr>
-        <p:style>
-          <a:lnRef idx="1">
-            <a:schemeClr val="accent1"/>
-          </a:lnRef>
-          <a:fillRef idx="3">
-            <a:schemeClr val="accent1"/>
-          </a:fillRef>
-          <a:effectRef idx="2">
-            <a:schemeClr val="accent1"/>
-          </a:effectRef>
-          <a:fontRef idx="minor">
-            <a:schemeClr val="lt1"/>
-          </a:fontRef>
-        </p:style>
-        <p:txBody>
-          <a:bodyPr rtlCol="0" anchor="ctr"/>
-          <a:lstStyle/>
-          <a:p>
-            <a:pPr algn="ctr"/>
-            <a:endParaRPr/>
-          </a:p>
-        </p:txBody>
-      </p:sp>
-      <p:sp>
-        <p:nvSpPr>
-          <p:cNvPr id="4" name="TextBox 3"/>
+          </a:p>
+        </p:txBody>
+      </p:sp>
+      <p:sp>
+        <p:nvSpPr>
+          <p:cNvPr id="3" name="TextBox 2"/>
           <p:cNvSpPr txBox="1"/>
           <p:nvPr/>
         </p:nvSpPr>
@@ -7254,11 +7171,10 @@
           <a:lstStyle/>
           <a:p>
             <a:pPr>
-              <a:defRPr sz="1000" b="1">
+              <a:defRPr sz="950" b="1">
                 <a:solidFill>
                   <a:srgbClr val="0EA5E9"/>
                 </a:solidFill>
-                <a:latin typeface="Arial"/>
               </a:defRPr>
             </a:pPr>
             <a:r>
@@ -7269,7 +7185,7 @@
       </p:sp>
       <p:sp>
         <p:nvSpPr>
-          <p:cNvPr id="5" name="TextBox 4"/>
+          <p:cNvPr id="4" name="TextBox 3"/>
           <p:cNvSpPr txBox="1"/>
           <p:nvPr/>
         </p:nvSpPr>
@@ -7290,127 +7206,52 @@
           <a:lstStyle/>
           <a:p>
             <a:pPr>
-              <a:defRPr sz="2200" b="1">
+              <a:defRPr sz="2000" b="1">
                 <a:solidFill>
                   <a:srgbClr val="FFFFFF"/>
                 </a:solidFill>
-                <a:latin typeface="Arial"/>
-              </a:defRPr>
-            </a:pPr>
-            <a:r>
-              <a:t>5. Object-Oriented Domain Entities &amp; UML Structure</a:t>
-            </a:r>
-          </a:p>
-        </p:txBody>
-      </p:sp>
-      <p:sp>
-        <p:nvSpPr>
-          <p:cNvPr id="6" name="Rounded Rectangle 5"/>
-          <p:cNvSpPr/>
-          <p:nvPr/>
-        </p:nvSpPr>
-        <p:spPr>
-          <a:xfrm>
-            <a:off x="731520" y="1280160"/>
-            <a:ext cx="3474720" cy="2240280"/>
-          </a:xfrm>
-          <a:prstGeom prst="roundRect">
-            <a:avLst/>
-          </a:prstGeom>
-          <a:solidFill>
-            <a:srgbClr val="FFFFFF"/>
-          </a:solidFill>
-          <a:ln w="12700">
-            <a:solidFill>
-              <a:srgbClr val="CBD5E1"/>
-            </a:solidFill>
-          </a:ln>
-        </p:spPr>
-        <p:style>
-          <a:lnRef idx="1">
-            <a:schemeClr val="accent1"/>
-          </a:lnRef>
-          <a:fillRef idx="3">
-            <a:schemeClr val="accent1"/>
-          </a:fillRef>
-          <a:effectRef idx="2">
-            <a:schemeClr val="accent1"/>
-          </a:effectRef>
-          <a:fontRef idx="minor">
-            <a:schemeClr val="lt1"/>
-          </a:fontRef>
-        </p:style>
-        <p:txBody>
-          <a:bodyPr rtlCol="0" anchor="ctr"/>
-          <a:lstStyle/>
-          <a:p>
-            <a:pPr algn="ctr"/>
-            <a:endParaRPr/>
-          </a:p>
-        </p:txBody>
-      </p:sp>
-      <p:sp>
-        <p:nvSpPr>
-          <p:cNvPr id="7" name="Rectangle 6"/>
-          <p:cNvSpPr/>
-          <p:nvPr/>
-        </p:nvSpPr>
-        <p:spPr>
-          <a:xfrm>
-            <a:off x="731520" y="1280160"/>
-            <a:ext cx="3474720" cy="384048"/>
+              </a:defRPr>
+            </a:pPr>
+            <a:r>
+              <a:t>3. Object-Oriented UML Class Diagram</a:t>
+            </a:r>
+          </a:p>
+        </p:txBody>
+      </p:sp>
+      <p:pic>
+        <p:nvPicPr>
+          <p:cNvPr id="5" name="Picture 4" descr="uml_class_diagram.png"/>
+          <p:cNvPicPr>
+            <a:picLocks noChangeAspect="1"/>
+          </p:cNvPicPr>
+          <p:nvPr/>
+        </p:nvPicPr>
+        <p:blipFill>
+          <a:blip r:embed="rId2"/>
+          <a:stretch>
+            <a:fillRect/>
+          </a:stretch>
+        </p:blipFill>
+        <p:spPr>
+          <a:xfrm>
+            <a:off x="731520" y="1188720"/>
+            <a:ext cx="10728655" cy="5120640"/>
           </a:xfrm>
           <a:prstGeom prst="rect">
             <a:avLst/>
           </a:prstGeom>
-          <a:solidFill>
-            <a:srgbClr val="0F172A"/>
-          </a:solidFill>
-          <a:ln>
-            <a:noFill/>
-          </a:ln>
-        </p:spPr>
-        <p:style>
-          <a:lnRef idx="1">
-            <a:schemeClr val="accent1"/>
-          </a:lnRef>
-          <a:fillRef idx="3">
-            <a:schemeClr val="accent1"/>
-          </a:fillRef>
-          <a:effectRef idx="2">
-            <a:schemeClr val="accent1"/>
-          </a:effectRef>
-          <a:fontRef idx="minor">
-            <a:schemeClr val="lt1"/>
-          </a:fontRef>
-        </p:style>
-        <p:txBody>
-          <a:bodyPr rtlCol="0" anchor="ctr"/>
-          <a:lstStyle/>
-          <a:p>
-            <a:pPr algn="ctr">
-              <a:defRPr sz="1200" b="1">
-                <a:solidFill>
-                  <a:srgbClr val="FFFFFF"/>
-                </a:solidFill>
-              </a:defRPr>
-            </a:pPr>
-            <a:r>
-              <a:t>Category | Domain Grouping</a:t>
-            </a:r>
-          </a:p>
-        </p:txBody>
-      </p:sp>
-      <p:sp>
-        <p:nvSpPr>
-          <p:cNvPr id="8" name="TextBox 7"/>
+        </p:spPr>
+      </p:pic>
+      <p:sp>
+        <p:nvSpPr>
+          <p:cNvPr id="6" name="TextBox 5"/>
           <p:cNvSpPr txBox="1"/>
           <p:nvPr/>
         </p:nvSpPr>
         <p:spPr>
           <a:xfrm>
-            <a:off x="822960" y="1737360"/>
-            <a:ext cx="3291840" cy="1691640"/>
+            <a:off x="731520" y="6446520"/>
+            <a:ext cx="10728655" cy="320040"/>
           </a:xfrm>
           <a:prstGeom prst="rect">
             <a:avLst/>
@@ -7418,828 +7259,20 @@
           <a:noFill/>
         </p:spPr>
         <p:txBody>
-          <a:bodyPr wrap="square">
+          <a:bodyPr wrap="none">
             <a:spAutoFit/>
           </a:bodyPr>
           <a:lstStyle/>
           <a:p>
             <a:pPr>
-              <a:spcBef>
-                <a:spcPts val="0"/>
-              </a:spcBef>
-              <a:defRPr sz="950">
-                <a:solidFill>
-                  <a:srgbClr val="0F172A"/>
-                </a:solidFill>
-              </a:defRPr>
-            </a:pPr>
-            <a:r>
-              <a:t>+ id: int [PK]</a:t>
-            </a:r>
-            <a:br/>
-            <a:r>
-              <a:t>+ name: string</a:t>
-            </a:r>
-            <a:br/>
-            <a:r>
-              <a:t>+ description: string</a:t>
-            </a:r>
-          </a:p>
-          <a:p>
-            <a:pPr>
-              <a:spcBef>
-                <a:spcPts val="400"/>
-              </a:spcBef>
-              <a:defRPr sz="950">
-                <a:solidFill>
-                  <a:srgbClr val="0F172A"/>
-                </a:solidFill>
-              </a:defRPr>
-            </a:pPr>
-            <a:r>
-              <a:t>+ getItems(): List&lt;InventoryItem&gt;</a:t>
-            </a:r>
-          </a:p>
-        </p:txBody>
-      </p:sp>
-      <p:sp>
-        <p:nvSpPr>
-          <p:cNvPr id="9" name="Rounded Rectangle 8"/>
-          <p:cNvSpPr/>
-          <p:nvPr/>
-        </p:nvSpPr>
-        <p:spPr>
-          <a:xfrm>
-            <a:off x="4343400" y="1280160"/>
-            <a:ext cx="3474720" cy="2240280"/>
-          </a:xfrm>
-          <a:prstGeom prst="roundRect">
-            <a:avLst/>
-          </a:prstGeom>
-          <a:solidFill>
-            <a:srgbClr val="FFFFFF"/>
-          </a:solidFill>
-          <a:ln w="12700">
-            <a:solidFill>
-              <a:srgbClr val="CBD5E1"/>
-            </a:solidFill>
-          </a:ln>
-        </p:spPr>
-        <p:style>
-          <a:lnRef idx="1">
-            <a:schemeClr val="accent1"/>
-          </a:lnRef>
-          <a:fillRef idx="3">
-            <a:schemeClr val="accent1"/>
-          </a:fillRef>
-          <a:effectRef idx="2">
-            <a:schemeClr val="accent1"/>
-          </a:effectRef>
-          <a:fontRef idx="minor">
-            <a:schemeClr val="lt1"/>
-          </a:fontRef>
-        </p:style>
-        <p:txBody>
-          <a:bodyPr rtlCol="0" anchor="ctr"/>
-          <a:lstStyle/>
-          <a:p>
-            <a:pPr algn="ctr"/>
-            <a:endParaRPr/>
-          </a:p>
-        </p:txBody>
-      </p:sp>
-      <p:sp>
-        <p:nvSpPr>
-          <p:cNvPr id="10" name="Rectangle 9"/>
-          <p:cNvSpPr/>
-          <p:nvPr/>
-        </p:nvSpPr>
-        <p:spPr>
-          <a:xfrm>
-            <a:off x="4343400" y="1280160"/>
-            <a:ext cx="3474720" cy="384048"/>
-          </a:xfrm>
-          <a:prstGeom prst="rect">
-            <a:avLst/>
-          </a:prstGeom>
-          <a:solidFill>
-            <a:srgbClr val="0F172A"/>
-          </a:solidFill>
-          <a:ln>
-            <a:noFill/>
-          </a:ln>
-        </p:spPr>
-        <p:style>
-          <a:lnRef idx="1">
-            <a:schemeClr val="accent1"/>
-          </a:lnRef>
-          <a:fillRef idx="3">
-            <a:schemeClr val="accent1"/>
-          </a:fillRef>
-          <a:effectRef idx="2">
-            <a:schemeClr val="accent1"/>
-          </a:effectRef>
-          <a:fontRef idx="minor">
-            <a:schemeClr val="lt1"/>
-          </a:fontRef>
-        </p:style>
-        <p:txBody>
-          <a:bodyPr rtlCol="0" anchor="ctr"/>
-          <a:lstStyle/>
-          <a:p>
-            <a:pPr algn="ctr">
-              <a:defRPr sz="1200" b="1">
-                <a:solidFill>
-                  <a:srgbClr val="FFFFFF"/>
-                </a:solidFill>
-              </a:defRPr>
-            </a:pPr>
-            <a:r>
-              <a:t>InventoryItem | Core Catalog Entity</a:t>
-            </a:r>
-          </a:p>
-        </p:txBody>
-      </p:sp>
-      <p:sp>
-        <p:nvSpPr>
-          <p:cNvPr id="11" name="TextBox 10"/>
-          <p:cNvSpPr txBox="1"/>
-          <p:nvPr/>
-        </p:nvSpPr>
-        <p:spPr>
-          <a:xfrm>
-            <a:off x="4434840" y="1737360"/>
-            <a:ext cx="3291840" cy="1691640"/>
-          </a:xfrm>
-          <a:prstGeom prst="rect">
-            <a:avLst/>
-          </a:prstGeom>
-          <a:noFill/>
-        </p:spPr>
-        <p:txBody>
-          <a:bodyPr wrap="square">
-            <a:spAutoFit/>
-          </a:bodyPr>
-          <a:lstStyle/>
-          <a:p>
-            <a:pPr>
-              <a:spcBef>
-                <a:spcPts val="0"/>
-              </a:spcBef>
-              <a:defRPr sz="950">
-                <a:solidFill>
-                  <a:srgbClr val="0F172A"/>
-                </a:solidFill>
-              </a:defRPr>
-            </a:pPr>
-            <a:r>
-              <a:t>+ id: int [PK]</a:t>
-            </a:r>
-            <a:br/>
-            <a:r>
-              <a:t>+ categoryId: int [FK]</a:t>
-            </a:r>
-            <a:br/>
-            <a:r>
-              <a:t>+ name: string</a:t>
-            </a:r>
-            <a:br/>
-            <a:r>
-              <a:t>+ unit: string</a:t>
-            </a:r>
-            <a:br/>
-            <a:r>
-              <a:t>+ minThreshold: float</a:t>
-            </a:r>
-          </a:p>
-          <a:p>
-            <a:pPr>
-              <a:spcBef>
-                <a:spcPts val="400"/>
-              </a:spcBef>
-              <a:defRPr sz="950">
-                <a:solidFill>
-                  <a:srgbClr val="0F172A"/>
-                </a:solidFill>
-              </a:defRPr>
-            </a:pPr>
-            <a:r>
-              <a:t>+ calculateCurrentStock(): float</a:t>
-            </a:r>
-            <a:br/>
-            <a:r>
-              <a:t>+ getNearestExpiration(): Date</a:t>
-            </a:r>
-            <a:br/>
-            <a:r>
-              <a:t>+ evaluateStatus(): StatusBadge</a:t>
-            </a:r>
-          </a:p>
-        </p:txBody>
-      </p:sp>
-      <p:sp>
-        <p:nvSpPr>
-          <p:cNvPr id="12" name="Rounded Rectangle 11"/>
-          <p:cNvSpPr/>
-          <p:nvPr/>
-        </p:nvSpPr>
-        <p:spPr>
-          <a:xfrm>
-            <a:off x="7955280" y="1280160"/>
-            <a:ext cx="3474720" cy="2240280"/>
-          </a:xfrm>
-          <a:prstGeom prst="roundRect">
-            <a:avLst/>
-          </a:prstGeom>
-          <a:solidFill>
-            <a:srgbClr val="FFFFFF"/>
-          </a:solidFill>
-          <a:ln w="12700">
-            <a:solidFill>
-              <a:srgbClr val="CBD5E1"/>
-            </a:solidFill>
-          </a:ln>
-        </p:spPr>
-        <p:style>
-          <a:lnRef idx="1">
-            <a:schemeClr val="accent1"/>
-          </a:lnRef>
-          <a:fillRef idx="3">
-            <a:schemeClr val="accent1"/>
-          </a:fillRef>
-          <a:effectRef idx="2">
-            <a:schemeClr val="accent1"/>
-          </a:effectRef>
-          <a:fontRef idx="minor">
-            <a:schemeClr val="lt1"/>
-          </a:fontRef>
-        </p:style>
-        <p:txBody>
-          <a:bodyPr rtlCol="0" anchor="ctr"/>
-          <a:lstStyle/>
-          <a:p>
-            <a:pPr algn="ctr"/>
-            <a:endParaRPr/>
-          </a:p>
-        </p:txBody>
-      </p:sp>
-      <p:sp>
-        <p:nvSpPr>
-          <p:cNvPr id="13" name="Rectangle 12"/>
-          <p:cNvSpPr/>
-          <p:nvPr/>
-        </p:nvSpPr>
-        <p:spPr>
-          <a:xfrm>
-            <a:off x="7955280" y="1280160"/>
-            <a:ext cx="3474720" cy="384048"/>
-          </a:xfrm>
-          <a:prstGeom prst="rect">
-            <a:avLst/>
-          </a:prstGeom>
-          <a:solidFill>
-            <a:srgbClr val="0F172A"/>
-          </a:solidFill>
-          <a:ln>
-            <a:noFill/>
-          </a:ln>
-        </p:spPr>
-        <p:style>
-          <a:lnRef idx="1">
-            <a:schemeClr val="accent1"/>
-          </a:lnRef>
-          <a:fillRef idx="3">
-            <a:schemeClr val="accent1"/>
-          </a:fillRef>
-          <a:effectRef idx="2">
-            <a:schemeClr val="accent1"/>
-          </a:effectRef>
-          <a:fontRef idx="minor">
-            <a:schemeClr val="lt1"/>
-          </a:fontRef>
-        </p:style>
-        <p:txBody>
-          <a:bodyPr rtlCol="0" anchor="ctr"/>
-          <a:lstStyle/>
-          <a:p>
-            <a:pPr algn="ctr">
-              <a:defRPr sz="1200" b="1">
-                <a:solidFill>
-                  <a:srgbClr val="FFFFFF"/>
-                </a:solidFill>
-              </a:defRPr>
-            </a:pPr>
-            <a:r>
-              <a:t>InventoryTransaction | Batch Movement Record</a:t>
-            </a:r>
-          </a:p>
-        </p:txBody>
-      </p:sp>
-      <p:sp>
-        <p:nvSpPr>
-          <p:cNvPr id="14" name="TextBox 13"/>
-          <p:cNvSpPr txBox="1"/>
-          <p:nvPr/>
-        </p:nvSpPr>
-        <p:spPr>
-          <a:xfrm>
-            <a:off x="8046720" y="1737360"/>
-            <a:ext cx="3291840" cy="1691640"/>
-          </a:xfrm>
-          <a:prstGeom prst="rect">
-            <a:avLst/>
-          </a:prstGeom>
-          <a:noFill/>
-        </p:spPr>
-        <p:txBody>
-          <a:bodyPr wrap="square">
-            <a:spAutoFit/>
-          </a:bodyPr>
-          <a:lstStyle/>
-          <a:p>
-            <a:pPr>
-              <a:spcBef>
-                <a:spcPts val="0"/>
-              </a:spcBef>
-              <a:defRPr sz="950">
-                <a:solidFill>
-                  <a:srgbClr val="0F172A"/>
-                </a:solidFill>
-              </a:defRPr>
-            </a:pPr>
-            <a:r>
-              <a:t>+ id: int [PK]</a:t>
-            </a:r>
-            <a:br/>
-            <a:r>
-              <a:t>+ itemId: int [FK]</a:t>
-            </a:r>
-            <a:br/>
-            <a:r>
-              <a:t>+ transactionType: 'IN'|'OUT'</a:t>
-            </a:r>
-            <a:br/>
-            <a:r>
-              <a:t>+ quantity: float</a:t>
-            </a:r>
-          </a:p>
-          <a:p>
-            <a:pPr>
-              <a:spcBef>
-                <a:spcPts val="400"/>
-              </a:spcBef>
-              <a:defRPr sz="950">
-                <a:solidFill>
-                  <a:srgbClr val="0F172A"/>
-                </a:solidFill>
-              </a:defRPr>
-            </a:pPr>
-            <a:r>
-              <a:t>+ purchaseDate: Date</a:t>
-            </a:r>
-            <a:br/>
-            <a:r>
-              <a:t>+ expirationDate: Date</a:t>
-            </a:r>
-            <a:br/>
-            <a:r>
-              <a:t>+ reason: string</a:t>
-            </a:r>
-          </a:p>
-        </p:txBody>
-      </p:sp>
-      <p:sp>
-        <p:nvSpPr>
-          <p:cNvPr id="15" name="Rounded Rectangle 14"/>
-          <p:cNvSpPr/>
-          <p:nvPr/>
-        </p:nvSpPr>
-        <p:spPr>
-          <a:xfrm>
-            <a:off x="731520" y="3703320"/>
-            <a:ext cx="3474720" cy="2240280"/>
-          </a:xfrm>
-          <a:prstGeom prst="roundRect">
-            <a:avLst/>
-          </a:prstGeom>
-          <a:solidFill>
-            <a:srgbClr val="FFFFFF"/>
-          </a:solidFill>
-          <a:ln w="12700">
-            <a:solidFill>
-              <a:srgbClr val="CBD5E1"/>
-            </a:solidFill>
-          </a:ln>
-        </p:spPr>
-        <p:style>
-          <a:lnRef idx="1">
-            <a:schemeClr val="accent1"/>
-          </a:lnRef>
-          <a:fillRef idx="3">
-            <a:schemeClr val="accent1"/>
-          </a:fillRef>
-          <a:effectRef idx="2">
-            <a:schemeClr val="accent1"/>
-          </a:effectRef>
-          <a:fontRef idx="minor">
-            <a:schemeClr val="lt1"/>
-          </a:fontRef>
-        </p:style>
-        <p:txBody>
-          <a:bodyPr rtlCol="0" anchor="ctr"/>
-          <a:lstStyle/>
-          <a:p>
-            <a:pPr algn="ctr"/>
-            <a:endParaRPr/>
-          </a:p>
-        </p:txBody>
-      </p:sp>
-      <p:sp>
-        <p:nvSpPr>
-          <p:cNvPr id="16" name="Rectangle 15"/>
-          <p:cNvSpPr/>
-          <p:nvPr/>
-        </p:nvSpPr>
-        <p:spPr>
-          <a:xfrm>
-            <a:off x="731520" y="3703320"/>
-            <a:ext cx="3474720" cy="384048"/>
-          </a:xfrm>
-          <a:prstGeom prst="rect">
-            <a:avLst/>
-          </a:prstGeom>
-          <a:solidFill>
-            <a:srgbClr val="0F172A"/>
-          </a:solidFill>
-          <a:ln>
-            <a:noFill/>
-          </a:ln>
-        </p:spPr>
-        <p:style>
-          <a:lnRef idx="1">
-            <a:schemeClr val="accent1"/>
-          </a:lnRef>
-          <a:fillRef idx="3">
-            <a:schemeClr val="accent1"/>
-          </a:fillRef>
-          <a:effectRef idx="2">
-            <a:schemeClr val="accent1"/>
-          </a:effectRef>
-          <a:fontRef idx="minor">
-            <a:schemeClr val="lt1"/>
-          </a:fontRef>
-        </p:style>
-        <p:txBody>
-          <a:bodyPr rtlCol="0" anchor="ctr"/>
-          <a:lstStyle/>
-          <a:p>
-            <a:pPr algn="ctr">
-              <a:defRPr sz="1200" b="1">
-                <a:solidFill>
-                  <a:srgbClr val="FFFFFF"/>
-                </a:solidFill>
-              </a:defRPr>
-            </a:pPr>
-            <a:r>
-              <a:t>AlertEngine | Telemetry Service</a:t>
-            </a:r>
-          </a:p>
-        </p:txBody>
-      </p:sp>
-      <p:sp>
-        <p:nvSpPr>
-          <p:cNvPr id="17" name="TextBox 16"/>
-          <p:cNvSpPr txBox="1"/>
-          <p:nvPr/>
-        </p:nvSpPr>
-        <p:spPr>
-          <a:xfrm>
-            <a:off x="822960" y="4160520"/>
-            <a:ext cx="3291840" cy="1691640"/>
-          </a:xfrm>
-          <a:prstGeom prst="rect">
-            <a:avLst/>
-          </a:prstGeom>
-          <a:noFill/>
-        </p:spPr>
-        <p:txBody>
-          <a:bodyPr wrap="square">
-            <a:spAutoFit/>
-          </a:bodyPr>
-          <a:lstStyle/>
-          <a:p>
-            <a:pPr>
-              <a:spcBef>
-                <a:spcPts val="0"/>
-              </a:spcBef>
-              <a:defRPr sz="950">
-                <a:solidFill>
-                  <a:srgbClr val="0F172A"/>
-                </a:solidFill>
-              </a:defRPr>
-            </a:pPr>
-            <a:r>
-              <a:t>+ evaluateExpiringLots(horizonDays=3): List&lt;Alert&gt;</a:t>
-            </a:r>
-            <a:br/>
-            <a:r>
-              <a:t>+ evaluateLowStock(): List&lt;ShoppingListItem&gt;</a:t>
-            </a:r>
-          </a:p>
-        </p:txBody>
-      </p:sp>
-      <p:sp>
-        <p:nvSpPr>
-          <p:cNvPr id="18" name="Rounded Rectangle 17"/>
-          <p:cNvSpPr/>
-          <p:nvPr/>
-        </p:nvSpPr>
-        <p:spPr>
-          <a:xfrm>
-            <a:off x="4343400" y="3703320"/>
-            <a:ext cx="3474720" cy="2240280"/>
-          </a:xfrm>
-          <a:prstGeom prst="roundRect">
-            <a:avLst/>
-          </a:prstGeom>
-          <a:solidFill>
-            <a:srgbClr val="FFFFFF"/>
-          </a:solidFill>
-          <a:ln w="12700">
-            <a:solidFill>
-              <a:srgbClr val="CBD5E1"/>
-            </a:solidFill>
-          </a:ln>
-        </p:spPr>
-        <p:style>
-          <a:lnRef idx="1">
-            <a:schemeClr val="accent1"/>
-          </a:lnRef>
-          <a:fillRef idx="3">
-            <a:schemeClr val="accent1"/>
-          </a:fillRef>
-          <a:effectRef idx="2">
-            <a:schemeClr val="accent1"/>
-          </a:effectRef>
-          <a:fontRef idx="minor">
-            <a:schemeClr val="lt1"/>
-          </a:fontRef>
-        </p:style>
-        <p:txBody>
-          <a:bodyPr rtlCol="0" anchor="ctr"/>
-          <a:lstStyle/>
-          <a:p>
-            <a:pPr algn="ctr"/>
-            <a:endParaRPr/>
-          </a:p>
-        </p:txBody>
-      </p:sp>
-      <p:sp>
-        <p:nvSpPr>
-          <p:cNvPr id="19" name="Rectangle 18"/>
-          <p:cNvSpPr/>
-          <p:nvPr/>
-        </p:nvSpPr>
-        <p:spPr>
-          <a:xfrm>
-            <a:off x="4343400" y="3703320"/>
-            <a:ext cx="3474720" cy="384048"/>
-          </a:xfrm>
-          <a:prstGeom prst="rect">
-            <a:avLst/>
-          </a:prstGeom>
-          <a:solidFill>
-            <a:srgbClr val="0F172A"/>
-          </a:solidFill>
-          <a:ln>
-            <a:noFill/>
-          </a:ln>
-        </p:spPr>
-        <p:style>
-          <a:lnRef idx="1">
-            <a:schemeClr val="accent1"/>
-          </a:lnRef>
-          <a:fillRef idx="3">
-            <a:schemeClr val="accent1"/>
-          </a:fillRef>
-          <a:effectRef idx="2">
-            <a:schemeClr val="accent1"/>
-          </a:effectRef>
-          <a:fontRef idx="minor">
-            <a:schemeClr val="lt1"/>
-          </a:fontRef>
-        </p:style>
-        <p:txBody>
-          <a:bodyPr rtlCol="0" anchor="ctr"/>
-          <a:lstStyle/>
-          <a:p>
-            <a:pPr algn="ctr">
-              <a:defRPr sz="1200" b="1">
-                <a:solidFill>
-                  <a:srgbClr val="FFFFFF"/>
-                </a:solidFill>
-              </a:defRPr>
-            </a:pPr>
-            <a:r>
-              <a:t>StockInPayload | Inbound DTO</a:t>
-            </a:r>
-          </a:p>
-        </p:txBody>
-      </p:sp>
-      <p:sp>
-        <p:nvSpPr>
-          <p:cNvPr id="20" name="TextBox 19"/>
-          <p:cNvSpPr txBox="1"/>
-          <p:nvPr/>
-        </p:nvSpPr>
-        <p:spPr>
-          <a:xfrm>
-            <a:off x="4434840" y="4160520"/>
-            <a:ext cx="3291840" cy="1691640"/>
-          </a:xfrm>
-          <a:prstGeom prst="rect">
-            <a:avLst/>
-          </a:prstGeom>
-          <a:noFill/>
-        </p:spPr>
-        <p:txBody>
-          <a:bodyPr wrap="square">
-            <a:spAutoFit/>
-          </a:bodyPr>
-          <a:lstStyle/>
-          <a:p>
-            <a:pPr>
-              <a:spcBef>
-                <a:spcPts val="0"/>
-              </a:spcBef>
-              <a:defRPr sz="950">
-                <a:solidFill>
-                  <a:srgbClr val="0F172A"/>
-                </a:solidFill>
-              </a:defRPr>
-            </a:pPr>
-            <a:r>
-              <a:t>+ itemId: int</a:t>
-            </a:r>
-            <a:br/>
-            <a:r>
-              <a:t>+ quantity: float</a:t>
-            </a:r>
-            <a:br/>
-            <a:r>
-              <a:t>+ purchaseDate: Date</a:t>
-            </a:r>
-            <a:br/>
-            <a:r>
-              <a:t>+ expirationDate: Date</a:t>
-            </a:r>
-            <a:br/>
-            <a:r>
-              <a:t>+ reason: string</a:t>
-            </a:r>
-          </a:p>
-        </p:txBody>
-      </p:sp>
-      <p:sp>
-        <p:nvSpPr>
-          <p:cNvPr id="21" name="Rounded Rectangle 20"/>
-          <p:cNvSpPr/>
-          <p:nvPr/>
-        </p:nvSpPr>
-        <p:spPr>
-          <a:xfrm>
-            <a:off x="7955280" y="3703320"/>
-            <a:ext cx="3474720" cy="2240280"/>
-          </a:xfrm>
-          <a:prstGeom prst="roundRect">
-            <a:avLst/>
-          </a:prstGeom>
-          <a:solidFill>
-            <a:srgbClr val="FFFFFF"/>
-          </a:solidFill>
-          <a:ln w="12700">
-            <a:solidFill>
-              <a:srgbClr val="CBD5E1"/>
-            </a:solidFill>
-          </a:ln>
-        </p:spPr>
-        <p:style>
-          <a:lnRef idx="1">
-            <a:schemeClr val="accent1"/>
-          </a:lnRef>
-          <a:fillRef idx="3">
-            <a:schemeClr val="accent1"/>
-          </a:fillRef>
-          <a:effectRef idx="2">
-            <a:schemeClr val="accent1"/>
-          </a:effectRef>
-          <a:fontRef idx="minor">
-            <a:schemeClr val="lt1"/>
-          </a:fontRef>
-        </p:style>
-        <p:txBody>
-          <a:bodyPr rtlCol="0" anchor="ctr"/>
-          <a:lstStyle/>
-          <a:p>
-            <a:pPr algn="ctr"/>
-            <a:endParaRPr/>
-          </a:p>
-        </p:txBody>
-      </p:sp>
-      <p:sp>
-        <p:nvSpPr>
-          <p:cNvPr id="22" name="Rectangle 21"/>
-          <p:cNvSpPr/>
-          <p:nvPr/>
-        </p:nvSpPr>
-        <p:spPr>
-          <a:xfrm>
-            <a:off x="7955280" y="3703320"/>
-            <a:ext cx="3474720" cy="384048"/>
-          </a:xfrm>
-          <a:prstGeom prst="rect">
-            <a:avLst/>
-          </a:prstGeom>
-          <a:solidFill>
-            <a:srgbClr val="0F172A"/>
-          </a:solidFill>
-          <a:ln>
-            <a:noFill/>
-          </a:ln>
-        </p:spPr>
-        <p:style>
-          <a:lnRef idx="1">
-            <a:schemeClr val="accent1"/>
-          </a:lnRef>
-          <a:fillRef idx="3">
-            <a:schemeClr val="accent1"/>
-          </a:fillRef>
-          <a:effectRef idx="2">
-            <a:schemeClr val="accent1"/>
-          </a:effectRef>
-          <a:fontRef idx="minor">
-            <a:schemeClr val="lt1"/>
-          </a:fontRef>
-        </p:style>
-        <p:txBody>
-          <a:bodyPr rtlCol="0" anchor="ctr"/>
-          <a:lstStyle/>
-          <a:p>
-            <a:pPr algn="ctr">
-              <a:defRPr sz="1200" b="1">
-                <a:solidFill>
-                  <a:srgbClr val="FFFFFF"/>
-                </a:solidFill>
-              </a:defRPr>
-            </a:pPr>
-            <a:r>
-              <a:t>StockOutPayload | Outbound DTO</a:t>
-            </a:r>
-          </a:p>
-        </p:txBody>
-      </p:sp>
-      <p:sp>
-        <p:nvSpPr>
-          <p:cNvPr id="23" name="TextBox 22"/>
-          <p:cNvSpPr txBox="1"/>
-          <p:nvPr/>
-        </p:nvSpPr>
-        <p:spPr>
-          <a:xfrm>
-            <a:off x="8046720" y="4160520"/>
-            <a:ext cx="3291840" cy="1691640"/>
-          </a:xfrm>
-          <a:prstGeom prst="rect">
-            <a:avLst/>
-          </a:prstGeom>
-          <a:noFill/>
-        </p:spPr>
-        <p:txBody>
-          <a:bodyPr wrap="square">
-            <a:spAutoFit/>
-          </a:bodyPr>
-          <a:lstStyle/>
-          <a:p>
-            <a:pPr>
-              <a:spcBef>
-                <a:spcPts val="0"/>
-              </a:spcBef>
-              <a:defRPr sz="950">
-                <a:solidFill>
-                  <a:srgbClr val="0F172A"/>
-                </a:solidFill>
-              </a:defRPr>
-            </a:pPr>
-            <a:r>
-              <a:t>+ itemId: int</a:t>
-            </a:r>
-            <a:br/>
-            <a:r>
-              <a:t>+ quantity: float</a:t>
-            </a:r>
-            <a:br/>
-            <a:r>
-              <a:t>+ reason: 'Used/Consumed'|'Spoiled/Expired'|'Transferred'</a:t>
+              <a:defRPr sz="900">
+                <a:solidFill>
+                  <a:srgbClr val="64748B"/>
+                </a:solidFill>
+              </a:defRPr>
+            </a:pPr>
+            <a:r>
+              <a:t>Refrigerator &amp; Pantry Inventory Subsystem (RIMS)   |   Slide 4 of 11</a:t>
             </a:r>
           </a:p>
         </p:txBody>
@@ -8287,9 +7320,7 @@
             <a:srgbClr val="0F172A"/>
           </a:solidFill>
           <a:ln>
-            <a:solidFill>
-              <a:srgbClr val="2563EB"/>
-            </a:solidFill>
+            <a:noFill/>
           </a:ln>
         </p:spPr>
         <p:style>
@@ -8311,57 +7342,12 @@
           <a:lstStyle/>
           <a:p>
             <a:pPr algn="ctr"/>
-            <a:endParaRPr/>
-          </a:p>
-        </p:txBody>
-      </p:sp>
-      <p:sp>
-        <p:nvSpPr>
-          <p:cNvPr id="3" name="Rectangle 2"/>
-          <p:cNvSpPr/>
-          <p:nvPr/>
-        </p:nvSpPr>
-        <p:spPr>
-          <a:xfrm>
-            <a:off x="0" y="1033271"/>
-            <a:ext cx="12191695" cy="36576"/>
-          </a:xfrm>
-          <a:prstGeom prst="rect">
-            <a:avLst/>
-          </a:prstGeom>
-          <a:solidFill>
-            <a:srgbClr val="2563EB"/>
-          </a:solidFill>
-          <a:ln>
-            <a:noFill/>
-          </a:ln>
-        </p:spPr>
-        <p:style>
-          <a:lnRef idx="1">
-            <a:schemeClr val="accent1"/>
-          </a:lnRef>
-          <a:fillRef idx="3">
-            <a:schemeClr val="accent1"/>
-          </a:fillRef>
-          <a:effectRef idx="2">
-            <a:schemeClr val="accent1"/>
-          </a:effectRef>
-          <a:fontRef idx="minor">
-            <a:schemeClr val="lt1"/>
-          </a:fontRef>
-        </p:style>
-        <p:txBody>
-          <a:bodyPr rtlCol="0" anchor="ctr"/>
-          <a:lstStyle/>
-          <a:p>
-            <a:pPr algn="ctr"/>
-            <a:endParaRPr/>
-          </a:p>
-        </p:txBody>
-      </p:sp>
-      <p:sp>
-        <p:nvSpPr>
-          <p:cNvPr id="4" name="TextBox 3"/>
+          </a:p>
+        </p:txBody>
+      </p:sp>
+      <p:sp>
+        <p:nvSpPr>
+          <p:cNvPr id="3" name="TextBox 2"/>
           <p:cNvSpPr txBox="1"/>
           <p:nvPr/>
         </p:nvSpPr>
@@ -8382,11 +7368,10 @@
           <a:lstStyle/>
           <a:p>
             <a:pPr>
-              <a:defRPr sz="1000" b="1">
+              <a:defRPr sz="950" b="1">
                 <a:solidFill>
                   <a:srgbClr val="0EA5E9"/>
                 </a:solidFill>
-                <a:latin typeface="Arial"/>
               </a:defRPr>
             </a:pPr>
             <a:r>
@@ -8397,7 +7382,7 @@
       </p:sp>
       <p:sp>
         <p:nvSpPr>
-          <p:cNvPr id="5" name="TextBox 4"/>
+          <p:cNvPr id="4" name="TextBox 3"/>
           <p:cNvSpPr txBox="1"/>
           <p:nvPr/>
         </p:nvSpPr>
@@ -8418,127 +7403,52 @@
           <a:lstStyle/>
           <a:p>
             <a:pPr>
-              <a:defRPr sz="2200" b="1">
+              <a:defRPr sz="2000" b="1">
                 <a:solidFill>
                   <a:srgbClr val="FFFFFF"/>
                 </a:solidFill>
-                <a:latin typeface="Arial"/>
-              </a:defRPr>
-            </a:pPr>
-            <a:r>
-              <a:t>6. Class-Responsibility-Collaborator (CRC) Cards</a:t>
-            </a:r>
-          </a:p>
-        </p:txBody>
-      </p:sp>
-      <p:sp>
-        <p:nvSpPr>
-          <p:cNvPr id="6" name="Rounded Rectangle 5"/>
-          <p:cNvSpPr/>
-          <p:nvPr/>
-        </p:nvSpPr>
-        <p:spPr>
-          <a:xfrm>
-            <a:off x="731520" y="1280160"/>
-            <a:ext cx="3474720" cy="4892040"/>
-          </a:xfrm>
-          <a:prstGeom prst="roundRect">
-            <a:avLst/>
-          </a:prstGeom>
-          <a:solidFill>
-            <a:srgbClr val="FFFFFF"/>
-          </a:solidFill>
-          <a:ln w="12700">
-            <a:solidFill>
-              <a:srgbClr val="CBD5E1"/>
-            </a:solidFill>
-          </a:ln>
-        </p:spPr>
-        <p:style>
-          <a:lnRef idx="1">
-            <a:schemeClr val="accent1"/>
-          </a:lnRef>
-          <a:fillRef idx="3">
-            <a:schemeClr val="accent1"/>
-          </a:fillRef>
-          <a:effectRef idx="2">
-            <a:schemeClr val="accent1"/>
-          </a:effectRef>
-          <a:fontRef idx="minor">
-            <a:schemeClr val="lt1"/>
-          </a:fontRef>
-        </p:style>
-        <p:txBody>
-          <a:bodyPr rtlCol="0" anchor="ctr"/>
-          <a:lstStyle/>
-          <a:p>
-            <a:pPr algn="ctr"/>
-            <a:endParaRPr/>
-          </a:p>
-        </p:txBody>
-      </p:sp>
-      <p:sp>
-        <p:nvSpPr>
-          <p:cNvPr id="7" name="Rectangle 6"/>
-          <p:cNvSpPr/>
-          <p:nvPr/>
-        </p:nvSpPr>
-        <p:spPr>
-          <a:xfrm>
-            <a:off x="731520" y="1280160"/>
-            <a:ext cx="3474720" cy="384048"/>
+              </a:defRPr>
+            </a:pPr>
+            <a:r>
+              <a:t>4. Class-Responsibility-Collaborator (CRC) Cards</a:t>
+            </a:r>
+          </a:p>
+        </p:txBody>
+      </p:sp>
+      <p:pic>
+        <p:nvPicPr>
+          <p:cNvPr id="5" name="Picture 4" descr="crc_cards_diagram.png"/>
+          <p:cNvPicPr>
+            <a:picLocks noChangeAspect="1"/>
+          </p:cNvPicPr>
+          <p:nvPr/>
+        </p:nvPicPr>
+        <p:blipFill>
+          <a:blip r:embed="rId2"/>
+          <a:stretch>
+            <a:fillRect/>
+          </a:stretch>
+        </p:blipFill>
+        <p:spPr>
+          <a:xfrm>
+            <a:off x="731520" y="1188720"/>
+            <a:ext cx="10728655" cy="5120640"/>
           </a:xfrm>
           <a:prstGeom prst="rect">
             <a:avLst/>
           </a:prstGeom>
-          <a:solidFill>
-            <a:srgbClr val="2563EB"/>
-          </a:solidFill>
-          <a:ln>
-            <a:noFill/>
-          </a:ln>
-        </p:spPr>
-        <p:style>
-          <a:lnRef idx="1">
-            <a:schemeClr val="accent1"/>
-          </a:lnRef>
-          <a:fillRef idx="3">
-            <a:schemeClr val="accent1"/>
-          </a:fillRef>
-          <a:effectRef idx="2">
-            <a:schemeClr val="accent1"/>
-          </a:effectRef>
-          <a:fontRef idx="minor">
-            <a:schemeClr val="lt1"/>
-          </a:fontRef>
-        </p:style>
-        <p:txBody>
-          <a:bodyPr rtlCol="0" anchor="ctr"/>
-          <a:lstStyle/>
-          <a:p>
-            <a:pPr algn="ctr">
-              <a:defRPr sz="1200" b="1">
-                <a:solidFill>
-                  <a:srgbClr val="FFFFFF"/>
-                </a:solidFill>
-              </a:defRPr>
-            </a:pPr>
-            <a:r>
-              <a:t>InventoryItem</a:t>
-            </a:r>
-          </a:p>
-        </p:txBody>
-      </p:sp>
-      <p:sp>
-        <p:nvSpPr>
-          <p:cNvPr id="8" name="TextBox 7"/>
+        </p:spPr>
+      </p:pic>
+      <p:sp>
+        <p:nvSpPr>
+          <p:cNvPr id="6" name="TextBox 5"/>
           <p:cNvSpPr txBox="1"/>
           <p:nvPr/>
         </p:nvSpPr>
         <p:spPr>
           <a:xfrm>
-            <a:off x="868680" y="1783080"/>
-            <a:ext cx="3200400" cy="4206240"/>
+            <a:off x="731520" y="6446520"/>
+            <a:ext cx="10728655" cy="320040"/>
           </a:xfrm>
           <a:prstGeom prst="rect">
             <a:avLst/>
@@ -8546,556 +7456,20 @@
           <a:noFill/>
         </p:spPr>
         <p:txBody>
-          <a:bodyPr wrap="square">
+          <a:bodyPr wrap="none">
             <a:spAutoFit/>
           </a:bodyPr>
           <a:lstStyle/>
           <a:p>
             <a:pPr>
-              <a:defRPr sz="1000" b="1">
-                <a:solidFill>
-                  <a:srgbClr val="0F172A"/>
-                </a:solidFill>
-              </a:defRPr>
-            </a:pPr>
-            <a:r>
-              <a:t>RESPONSIBILITIES (What it Does):</a:t>
-            </a:r>
-          </a:p>
-          <a:p>
-            <a:pPr>
-              <a:spcBef>
-                <a:spcPts val="300"/>
-              </a:spcBef>
-              <a:defRPr sz="950">
-                <a:solidFill>
-                  <a:srgbClr val="0F172A"/>
-                </a:solidFill>
-              </a:defRPr>
-            </a:pPr>
-            <a:r>
-              <a:t>• Maintains item name, category, unit, and min threshold</a:t>
-            </a:r>
-          </a:p>
-          <a:p>
-            <a:pPr>
-              <a:spcBef>
-                <a:spcPts val="300"/>
-              </a:spcBef>
-              <a:defRPr sz="950">
-                <a:solidFill>
-                  <a:srgbClr val="0F172A"/>
-                </a:solidFill>
-              </a:defRPr>
-            </a:pPr>
-            <a:r>
-              <a:t>• Aggregates total stock balance from transactions</a:t>
-            </a:r>
-          </a:p>
-          <a:p>
-            <a:pPr>
-              <a:spcBef>
-                <a:spcPts val="300"/>
-              </a:spcBef>
-              <a:defRPr sz="950">
-                <a:solidFill>
-                  <a:srgbClr val="0F172A"/>
-                </a:solidFill>
-              </a:defRPr>
-            </a:pPr>
-            <a:r>
-              <a:t>• Evaluates health status (Sufficient, Low, Expiring)</a:t>
-            </a:r>
-          </a:p>
-          <a:p>
-            <a:pPr>
-              <a:spcBef>
-                <a:spcPts val="1400"/>
-              </a:spcBef>
-              <a:defRPr sz="1000" b="1">
-                <a:solidFill>
-                  <a:srgbClr val="2563EB"/>
-                </a:solidFill>
-              </a:defRPr>
-            </a:pPr>
-            <a:r>
-              <a:t>COLLABORATORS (Interacts With):</a:t>
-            </a:r>
-          </a:p>
-          <a:p>
-            <a:pPr>
-              <a:spcBef>
-                <a:spcPts val="300"/>
-              </a:spcBef>
-              <a:defRPr sz="950">
-                <a:solidFill>
-                  <a:srgbClr val="0F172A"/>
-                </a:solidFill>
-              </a:defRPr>
-            </a:pPr>
-            <a:r>
-              <a:t>• Category</a:t>
-            </a:r>
-          </a:p>
-          <a:p>
-            <a:pPr>
-              <a:spcBef>
-                <a:spcPts val="300"/>
-              </a:spcBef>
-              <a:defRPr sz="950">
-                <a:solidFill>
-                  <a:srgbClr val="0F172A"/>
-                </a:solidFill>
-              </a:defRPr>
-            </a:pPr>
-            <a:r>
-              <a:t>• InventoryTransaction</a:t>
-            </a:r>
-          </a:p>
-          <a:p>
-            <a:pPr>
-              <a:spcBef>
-                <a:spcPts val="300"/>
-              </a:spcBef>
-              <a:defRPr sz="950">
-                <a:solidFill>
-                  <a:srgbClr val="0F172A"/>
-                </a:solidFill>
-              </a:defRPr>
-            </a:pPr>
-            <a:r>
-              <a:t>• AlertEngine</a:t>
-            </a:r>
-          </a:p>
-        </p:txBody>
-      </p:sp>
-      <p:sp>
-        <p:nvSpPr>
-          <p:cNvPr id="9" name="Rounded Rectangle 8"/>
-          <p:cNvSpPr/>
-          <p:nvPr/>
-        </p:nvSpPr>
-        <p:spPr>
-          <a:xfrm>
-            <a:off x="4343400" y="1280160"/>
-            <a:ext cx="3474720" cy="4892040"/>
-          </a:xfrm>
-          <a:prstGeom prst="roundRect">
-            <a:avLst/>
-          </a:prstGeom>
-          <a:solidFill>
-            <a:srgbClr val="FFFFFF"/>
-          </a:solidFill>
-          <a:ln w="12700">
-            <a:solidFill>
-              <a:srgbClr val="CBD5E1"/>
-            </a:solidFill>
-          </a:ln>
-        </p:spPr>
-        <p:style>
-          <a:lnRef idx="1">
-            <a:schemeClr val="accent1"/>
-          </a:lnRef>
-          <a:fillRef idx="3">
-            <a:schemeClr val="accent1"/>
-          </a:fillRef>
-          <a:effectRef idx="2">
-            <a:schemeClr val="accent1"/>
-          </a:effectRef>
-          <a:fontRef idx="minor">
-            <a:schemeClr val="lt1"/>
-          </a:fontRef>
-        </p:style>
-        <p:txBody>
-          <a:bodyPr rtlCol="0" anchor="ctr"/>
-          <a:lstStyle/>
-          <a:p>
-            <a:pPr algn="ctr"/>
-            <a:endParaRPr/>
-          </a:p>
-        </p:txBody>
-      </p:sp>
-      <p:sp>
-        <p:nvSpPr>
-          <p:cNvPr id="10" name="Rectangle 9"/>
-          <p:cNvSpPr/>
-          <p:nvPr/>
-        </p:nvSpPr>
-        <p:spPr>
-          <a:xfrm>
-            <a:off x="4343400" y="1280160"/>
-            <a:ext cx="3474720" cy="384048"/>
-          </a:xfrm>
-          <a:prstGeom prst="rect">
-            <a:avLst/>
-          </a:prstGeom>
-          <a:solidFill>
-            <a:srgbClr val="1E40AF"/>
-          </a:solidFill>
-          <a:ln>
-            <a:noFill/>
-          </a:ln>
-        </p:spPr>
-        <p:style>
-          <a:lnRef idx="1">
-            <a:schemeClr val="accent1"/>
-          </a:lnRef>
-          <a:fillRef idx="3">
-            <a:schemeClr val="accent1"/>
-          </a:fillRef>
-          <a:effectRef idx="2">
-            <a:schemeClr val="accent1"/>
-          </a:effectRef>
-          <a:fontRef idx="minor">
-            <a:schemeClr val="lt1"/>
-          </a:fontRef>
-        </p:style>
-        <p:txBody>
-          <a:bodyPr rtlCol="0" anchor="ctr"/>
-          <a:lstStyle/>
-          <a:p>
-            <a:pPr algn="ctr">
-              <a:defRPr sz="1200" b="1">
-                <a:solidFill>
-                  <a:srgbClr val="FFFFFF"/>
-                </a:solidFill>
-              </a:defRPr>
-            </a:pPr>
-            <a:r>
-              <a:t>InventoryTransaction</a:t>
-            </a:r>
-          </a:p>
-        </p:txBody>
-      </p:sp>
-      <p:sp>
-        <p:nvSpPr>
-          <p:cNvPr id="11" name="TextBox 10"/>
-          <p:cNvSpPr txBox="1"/>
-          <p:nvPr/>
-        </p:nvSpPr>
-        <p:spPr>
-          <a:xfrm>
-            <a:off x="4480560" y="1783080"/>
-            <a:ext cx="3200400" cy="4206240"/>
-          </a:xfrm>
-          <a:prstGeom prst="rect">
-            <a:avLst/>
-          </a:prstGeom>
-          <a:noFill/>
-        </p:spPr>
-        <p:txBody>
-          <a:bodyPr wrap="square">
-            <a:spAutoFit/>
-          </a:bodyPr>
-          <a:lstStyle/>
-          <a:p>
-            <a:pPr>
-              <a:defRPr sz="1000" b="1">
-                <a:solidFill>
-                  <a:srgbClr val="0F172A"/>
-                </a:solidFill>
-              </a:defRPr>
-            </a:pPr>
-            <a:r>
-              <a:t>RESPONSIBILITIES (What it Does):</a:t>
-            </a:r>
-          </a:p>
-          <a:p>
-            <a:pPr>
-              <a:spcBef>
-                <a:spcPts val="300"/>
-              </a:spcBef>
-              <a:defRPr sz="950">
-                <a:solidFill>
-                  <a:srgbClr val="0F172A"/>
-                </a:solidFill>
-              </a:defRPr>
-            </a:pPr>
-            <a:r>
-              <a:t>• Records individual batch inflow and consumption outflow</a:t>
-            </a:r>
-          </a:p>
-          <a:p>
-            <a:pPr>
-              <a:spcBef>
-                <a:spcPts val="300"/>
-              </a:spcBef>
-              <a:defRPr sz="950">
-                <a:solidFill>
-                  <a:srgbClr val="0F172A"/>
-                </a:solidFill>
-              </a:defRPr>
-            </a:pPr>
-            <a:r>
-              <a:t>• Tracks specific purchase and expiration dates</a:t>
-            </a:r>
-          </a:p>
-          <a:p>
-            <a:pPr>
-              <a:spcBef>
-                <a:spcPts val="300"/>
-              </a:spcBef>
-              <a:defRPr sz="950">
-                <a:solidFill>
-                  <a:srgbClr val="0F172A"/>
-                </a:solidFill>
-              </a:defRPr>
-            </a:pPr>
-            <a:r>
-              <a:t>• Logs reason classification</a:t>
-            </a:r>
-          </a:p>
-          <a:p>
-            <a:pPr>
-              <a:spcBef>
-                <a:spcPts val="1400"/>
-              </a:spcBef>
-              <a:defRPr sz="1000" b="1">
-                <a:solidFill>
-                  <a:srgbClr val="2563EB"/>
-                </a:solidFill>
-              </a:defRPr>
-            </a:pPr>
-            <a:r>
-              <a:t>COLLABORATORS (Interacts With):</a:t>
-            </a:r>
-          </a:p>
-          <a:p>
-            <a:pPr>
-              <a:spcBef>
-                <a:spcPts val="300"/>
-              </a:spcBef>
-              <a:defRPr sz="950">
-                <a:solidFill>
-                  <a:srgbClr val="0F172A"/>
-                </a:solidFill>
-              </a:defRPr>
-            </a:pPr>
-            <a:r>
-              <a:t>• InventoryItem</a:t>
-            </a:r>
-          </a:p>
-        </p:txBody>
-      </p:sp>
-      <p:sp>
-        <p:nvSpPr>
-          <p:cNvPr id="12" name="Rounded Rectangle 11"/>
-          <p:cNvSpPr/>
-          <p:nvPr/>
-        </p:nvSpPr>
-        <p:spPr>
-          <a:xfrm>
-            <a:off x="7955280" y="1280160"/>
-            <a:ext cx="3474720" cy="4892040"/>
-          </a:xfrm>
-          <a:prstGeom prst="roundRect">
-            <a:avLst/>
-          </a:prstGeom>
-          <a:solidFill>
-            <a:srgbClr val="FFFFFF"/>
-          </a:solidFill>
-          <a:ln w="12700">
-            <a:solidFill>
-              <a:srgbClr val="CBD5E1"/>
-            </a:solidFill>
-          </a:ln>
-        </p:spPr>
-        <p:style>
-          <a:lnRef idx="1">
-            <a:schemeClr val="accent1"/>
-          </a:lnRef>
-          <a:fillRef idx="3">
-            <a:schemeClr val="accent1"/>
-          </a:fillRef>
-          <a:effectRef idx="2">
-            <a:schemeClr val="accent1"/>
-          </a:effectRef>
-          <a:fontRef idx="minor">
-            <a:schemeClr val="lt1"/>
-          </a:fontRef>
-        </p:style>
-        <p:txBody>
-          <a:bodyPr rtlCol="0" anchor="ctr"/>
-          <a:lstStyle/>
-          <a:p>
-            <a:pPr algn="ctr"/>
-            <a:endParaRPr/>
-          </a:p>
-        </p:txBody>
-      </p:sp>
-      <p:sp>
-        <p:nvSpPr>
-          <p:cNvPr id="13" name="Rectangle 12"/>
-          <p:cNvSpPr/>
-          <p:nvPr/>
-        </p:nvSpPr>
-        <p:spPr>
-          <a:xfrm>
-            <a:off x="7955280" y="1280160"/>
-            <a:ext cx="3474720" cy="384048"/>
-          </a:xfrm>
-          <a:prstGeom prst="rect">
-            <a:avLst/>
-          </a:prstGeom>
-          <a:solidFill>
-            <a:srgbClr val="10B981"/>
-          </a:solidFill>
-          <a:ln>
-            <a:noFill/>
-          </a:ln>
-        </p:spPr>
-        <p:style>
-          <a:lnRef idx="1">
-            <a:schemeClr val="accent1"/>
-          </a:lnRef>
-          <a:fillRef idx="3">
-            <a:schemeClr val="accent1"/>
-          </a:fillRef>
-          <a:effectRef idx="2">
-            <a:schemeClr val="accent1"/>
-          </a:effectRef>
-          <a:fontRef idx="minor">
-            <a:schemeClr val="lt1"/>
-          </a:fontRef>
-        </p:style>
-        <p:txBody>
-          <a:bodyPr rtlCol="0" anchor="ctr"/>
-          <a:lstStyle/>
-          <a:p>
-            <a:pPr algn="ctr">
-              <a:defRPr sz="1200" b="1">
-                <a:solidFill>
-                  <a:srgbClr val="FFFFFF"/>
-                </a:solidFill>
-              </a:defRPr>
-            </a:pPr>
-            <a:r>
-              <a:t>AlertEngine</a:t>
-            </a:r>
-          </a:p>
-        </p:txBody>
-      </p:sp>
-      <p:sp>
-        <p:nvSpPr>
-          <p:cNvPr id="14" name="TextBox 13"/>
-          <p:cNvSpPr txBox="1"/>
-          <p:nvPr/>
-        </p:nvSpPr>
-        <p:spPr>
-          <a:xfrm>
-            <a:off x="8092440" y="1783080"/>
-            <a:ext cx="3200400" cy="4206240"/>
-          </a:xfrm>
-          <a:prstGeom prst="rect">
-            <a:avLst/>
-          </a:prstGeom>
-          <a:noFill/>
-        </p:spPr>
-        <p:txBody>
-          <a:bodyPr wrap="square">
-            <a:spAutoFit/>
-          </a:bodyPr>
-          <a:lstStyle/>
-          <a:p>
-            <a:pPr>
-              <a:defRPr sz="1000" b="1">
-                <a:solidFill>
-                  <a:srgbClr val="0F172A"/>
-                </a:solidFill>
-              </a:defRPr>
-            </a:pPr>
-            <a:r>
-              <a:t>RESPONSIBILITIES (What it Does):</a:t>
-            </a:r>
-          </a:p>
-          <a:p>
-            <a:pPr>
-              <a:spcBef>
-                <a:spcPts val="300"/>
-              </a:spcBef>
-              <a:defRPr sz="950">
-                <a:solidFill>
-                  <a:srgbClr val="0F172A"/>
-                </a:solidFill>
-              </a:defRPr>
-            </a:pPr>
-            <a:r>
-              <a:t>• Scans batch expiration dates against today's date</a:t>
-            </a:r>
-          </a:p>
-          <a:p>
-            <a:pPr>
-              <a:spcBef>
-                <a:spcPts val="300"/>
-              </a:spcBef>
-              <a:defRPr sz="950">
-                <a:solidFill>
-                  <a:srgbClr val="0F172A"/>
-                </a:solidFill>
-              </a:defRPr>
-            </a:pPr>
-            <a:r>
-              <a:t>• Emits 3-day lookahead Expiring Soon alerts</a:t>
-            </a:r>
-          </a:p>
-          <a:p>
-            <a:pPr>
-              <a:spcBef>
-                <a:spcPts val="300"/>
-              </a:spcBef>
-              <a:defRPr sz="950">
-                <a:solidFill>
-                  <a:srgbClr val="0F172A"/>
-                </a:solidFill>
-              </a:defRPr>
-            </a:pPr>
-            <a:r>
-              <a:t>• Compiles Low Stock items into Shopping List</a:t>
-            </a:r>
-          </a:p>
-          <a:p>
-            <a:pPr>
-              <a:spcBef>
-                <a:spcPts val="1400"/>
-              </a:spcBef>
-              <a:defRPr sz="1000" b="1">
-                <a:solidFill>
-                  <a:srgbClr val="2563EB"/>
-                </a:solidFill>
-              </a:defRPr>
-            </a:pPr>
-            <a:r>
-              <a:t>COLLABORATORS (Interacts With):</a:t>
-            </a:r>
-          </a:p>
-          <a:p>
-            <a:pPr>
-              <a:spcBef>
-                <a:spcPts val="300"/>
-              </a:spcBef>
-              <a:defRPr sz="950">
-                <a:solidFill>
-                  <a:srgbClr val="0F172A"/>
-                </a:solidFill>
-              </a:defRPr>
-            </a:pPr>
-            <a:r>
-              <a:t>• InventoryItem</a:t>
-            </a:r>
-          </a:p>
-          <a:p>
-            <a:pPr>
-              <a:spcBef>
-                <a:spcPts val="300"/>
-              </a:spcBef>
-              <a:defRPr sz="950">
-                <a:solidFill>
-                  <a:srgbClr val="0F172A"/>
-                </a:solidFill>
-              </a:defRPr>
-            </a:pPr>
-            <a:r>
-              <a:t>• InventoryTransaction</a:t>
+              <a:defRPr sz="900">
+                <a:solidFill>
+                  <a:srgbClr val="64748B"/>
+                </a:solidFill>
+              </a:defRPr>
+            </a:pPr>
+            <a:r>
+              <a:t>Refrigerator &amp; Pantry Inventory Subsystem (RIMS)   |   Slide 5 of 11</a:t>
             </a:r>
           </a:p>
         </p:txBody>

</xml_diff>